<commit_message>
Simplify script wording to easier vocabulary
Replace harder words (introduce, energetic, composed, call to action,
led the design, presenter) with simpler everyday words, and update
both the script doc and embedded PPTX speaker notes.

https://claude.ai/code/session_01Uf7TTcfNR9vtAVaxKyajv3
</commit_message>
<xml_diff>
--- a/Exercise_Motivation_A1_English_Final.pptx
+++ b/Exercise_Motivation_A1_English_Final.pptx
@@ -542,7 +542,7 @@
           <a:lstStyle/>
           <a:p>
             <a:r>
-              <a:t>Good morning, everyone! Today, we will introduce a song we made about exercise. Our team members are Lee Minjae, Lee Yeongu, Lee Insung, and Lee Hayul. Let's start!</a:t>
+              <a:t>Good morning, everyone! Today, we will talk about a song we made about exercise. Our team is Lee Minjae, Lee Yeongu, Lee Insung, and Lee Hayul. Let's start!</a:t>
             </a:r>
           </a:p>
         </p:txBody>
@@ -612,7 +612,7 @@
           <a:lstStyle/>
           <a:p>
             <a:r>
-              <a:t>Now, let's listen to our whole song! It is called "Kids Who Exercise." We wrote the words ourselves and made the music with Suno AI. You can read the lyrics on the screen as you listen. The song starts with a warning, and then it becomes happy and exciting. Let's play the full song now — it is about two minutes. (Click play now and listen to the whole song, about 2 minutes 5 seconds.)</a:t>
+              <a:t>Now, let's listen to our whole song! It is called "Kids Who Exercise." We wrote the words, and we made the music with Suno AI. You can read the words on the screen. First, the song gives a warning. Then it becomes happy and fun. Let's play the whole song now — it is about two minutes. (Click play now and listen to the whole song, about 2 minutes 5 seconds.)</a:t>
             </a:r>
           </a:p>
         </p:txBody>
@@ -682,7 +682,7 @@
           <a:lstStyle/>
           <a:p>
             <a:r>
-              <a:t>So, what is our song about? We made a song called "Kids Who Exercise." It is about exercise and healthy morning habits. We wrote the lyrics and made the music using Suno AI. The song starts with a warning about skipping breakfast and not moving, then becomes a happy, energetic song about exercising every day. We hope it makes you want to move!</a:t>
+              <a:t>We made this song for our English class. It is called "Kids Who Exercise." It is about exercise and good morning habits. We wrote the words, and we used Suno AI for the music. First, the song gives a warning about skipping breakfast. Then it becomes a happy song about exercising every day. We hope it makes you want to move!</a:t>
             </a:r>
           </a:p>
         </p:txBody>
@@ -752,7 +752,7 @@
           <a:lstStyle/>
           <a:p>
             <a:r>
-              <a:t>Let's look at what our song says. Verse 1 talks about a morning with no breakfast and no exercise, which feels hard and tiring. The chorus says: "Let's go take a walk outside, exercise every day, feel the pride!" Verse 2 and the bridge talk about moving your body and eating well to make every day more fun. Our song moves from a warning to an exciting call to action.</a:t>
+              <a:t>The most important part is the chorus: "Let's go take a walk outside, exercise every day, feel the pride!" First, our song gives a warning. Then it tells us to take action. Small daily habits, like a morning walk and a good breakfast, can make us healthier and happier.</a:t>
             </a:r>
           </a:p>
         </p:txBody>
@@ -962,7 +962,7 @@
           <a:lstStyle/>
           <a:p>
             <a:r>
-              <a:t>Here is our team: Lee Minjae wrote the script, Lee Yeongu made the design, Lee Insung was our presenter, and Lee Hayul, our team leader, made the song. Let's keep going!</a:t>
+              <a:t>Here is our team: Lee Minjae wrote the script, Lee Yeongu made the design, Lee Insung was our speaker, and Lee Hayul, our team leader, made the song with Suno AI.</a:t>
             </a:r>
           </a:p>
         </p:txBody>

</xml_diff>

<commit_message>
Reduce repetition between slides and script
Differentiate each slide's narration: slide 3 now covers the song's
background, slide 4 focuses on the chorus message without restating
the warning/habit framing, and slide 6's conclusion uses fresh wording
instead of repeating the warning-to-hope structure.

https://claude.ai/code/session_01Uf7TTcfNR9vtAVaxKyajv3
</commit_message>
<xml_diff>
--- a/Exercise_Motivation_A1_English_Final.pptx
+++ b/Exercise_Motivation_A1_English_Final.pptx
@@ -682,7 +682,7 @@
           <a:lstStyle/>
           <a:p>
             <a:r>
-              <a:t>We made this song for our English class. It is called "Kids Who Exercise." It is about exercise and good morning habits. We wrote the words, and we used Suno AI for the music. First, the song gives a warning about skipping breakfast. Then it becomes a happy song about exercising every day. We hope it makes you want to move!</a:t>
+              <a:t>We made this song for our English class. It is called "Kids Who Exercise." We wrote the words ourselves, and we used Suno AI for the music. We wanted to share a simple message about exercise in a fun way.</a:t>
             </a:r>
           </a:p>
         </p:txBody>
@@ -752,7 +752,7 @@
           <a:lstStyle/>
           <a:p>
             <a:r>
-              <a:t>The most important part is the chorus: "Let's go take a walk outside, exercise every day, feel the pride!" First, our song gives a warning. Then it tells us to take action. Small daily habits, like a morning walk and a good breakfast, can make us healthier and happier.</a:t>
+              <a:t>The chorus is the heart of our song: "Let's go take a walk outside, exercise every day, feel the pride!" This is our main message. Even a short walk can make you feel good about yourself.</a:t>
             </a:r>
           </a:p>
         </p:txBody>
@@ -892,7 +892,7 @@
           <a:lstStyle/>
           <a:p>
             <a:r>
-              <a:t>In conclusion, here is our song's message: "Move today for a better tomorrow." This is the main message of our song. It starts with a warning, but it ends with hope: small steps today can change tomorrow. Listen to our song, and start moving, one step at a time!</a:t>
+              <a:t>So, what is the big idea of our song? "Move today for a better tomorrow." One small action, like a short walk, can change how you feel. We hope this song gives you a reason to get up and try it!</a:t>
             </a:r>
           </a:p>
         </p:txBody>

</xml_diff>